<commit_message>
Remove build-machine paths from deck image descriptions
The 25 slide images carried alt-text descriptions containing local
build paths; each now carries just the image filename.
</commit_message>
<xml_diff>
--- a/companions/open-iga-operating-framework-deck.pptx
+++ b/companions/open-iga-operating-framework-deck.pptx
@@ -3500,7 +3500,7 @@
       </p:sp>
       <p:pic>
         <p:nvPicPr>
-          <p:cNvPr id="3" name="Image 0" descr="/home/claude/deckbuild/pngwarm/strip-04-prioritization.png">    </p:cNvPr>
+          <p:cNvPr id="3" name="Image 0" descr="strip-04-prioritization.png">    </p:cNvPr>
           <p:cNvPicPr>
             <a:picLocks noChangeAspect="1"/>
           </p:cNvPicPr>
@@ -3563,7 +3563,7 @@
       </p:sp>
       <p:pic>
         <p:nvPicPr>
-          <p:cNvPr id="5" name="Image 1" descr="/home/claude/deckbuild/pngwarm/d-layer4.png">    </p:cNvPr>
+          <p:cNvPr id="5" name="Image 1" descr="d-layer4.png">    </p:cNvPr>
           <p:cNvPicPr>
             <a:picLocks noChangeAspect="1"/>
           </p:cNvPicPr>
@@ -3848,7 +3848,7 @@
       </p:sp>
       <p:pic>
         <p:nvPicPr>
-          <p:cNvPr id="3" name="Image 0" descr="/home/claude/deckbuild/pngwarm/strip-05-process.png">    </p:cNvPr>
+          <p:cNvPr id="3" name="Image 0" descr="strip-05-process.png">    </p:cNvPr>
           <p:cNvPicPr>
             <a:picLocks noChangeAspect="1"/>
           </p:cNvPicPr>
@@ -3911,7 +3911,7 @@
       </p:sp>
       <p:pic>
         <p:nvPicPr>
-          <p:cNvPr id="5" name="Image 1" descr="/home/claude/deckbuild/pngwarm/d-layer5.png">    </p:cNvPr>
+          <p:cNvPr id="5" name="Image 1" descr="d-layer5.png">    </p:cNvPr>
           <p:cNvPicPr>
             <a:picLocks noChangeAspect="1"/>
           </p:cNvPicPr>
@@ -4196,7 +4196,7 @@
       </p:sp>
       <p:pic>
         <p:nvPicPr>
-          <p:cNvPr id="3" name="Image 0" descr="/home/claude/deckbuild/pngwarm/strip-06-cadence.png">    </p:cNvPr>
+          <p:cNvPr id="3" name="Image 0" descr="strip-06-cadence.png">    </p:cNvPr>
           <p:cNvPicPr>
             <a:picLocks noChangeAspect="1"/>
           </p:cNvPicPr>
@@ -4259,7 +4259,7 @@
       </p:sp>
       <p:pic>
         <p:nvPicPr>
-          <p:cNvPr id="5" name="Image 1" descr="/home/claude/deckbuild/pngwarm/d-layer6.png">    </p:cNvPr>
+          <p:cNvPr id="5" name="Image 1" descr="d-layer6.png">    </p:cNvPr>
           <p:cNvPicPr>
             <a:picLocks noChangeAspect="1"/>
           </p:cNvPicPr>
@@ -4544,7 +4544,7 @@
       </p:sp>
       <p:pic>
         <p:nvPicPr>
-          <p:cNvPr id="3" name="Image 0" descr="/home/claude/deckbuild/pngwarm/d-signals.png">    </p:cNvPr>
+          <p:cNvPr id="3" name="Image 0" descr="d-signals.png">    </p:cNvPr>
           <p:cNvPicPr>
             <a:picLocks noChangeAspect="1"/>
           </p:cNvPicPr>
@@ -4685,7 +4685,7 @@
       </p:sp>
       <p:pic>
         <p:nvPicPr>
-          <p:cNvPr id="3" name="Image 0" descr="/home/claude/deckbuild/pngwarm/fig-02-lifecycle.png">    </p:cNvPr>
+          <p:cNvPr id="3" name="Image 0" descr="fig-02-lifecycle.png">    </p:cNvPr>
           <p:cNvPicPr>
             <a:picLocks noChangeAspect="1"/>
           </p:cNvPicPr>
@@ -5049,7 +5049,7 @@
       </p:sp>
       <p:pic>
         <p:nvPicPr>
-          <p:cNvPr id="3" name="Image 0" descr="/home/claude/deckbuild/pngwarm/d-belt.png">    </p:cNvPr>
+          <p:cNvPr id="3" name="Image 0" descr="d-belt.png">    </p:cNvPr>
           <p:cNvPicPr>
             <a:picLocks noChangeAspect="1"/>
           </p:cNvPicPr>
@@ -5483,7 +5483,7 @@
       </p:sp>
       <p:pic>
         <p:nvPicPr>
-          <p:cNvPr id="3" name="Image 0" descr="/home/claude/deckbuild/pngwarm/fig-06-entitlement-drift.png">    </p:cNvPr>
+          <p:cNvPr id="3" name="Image 0" descr="fig-06-entitlement-drift.png">    </p:cNvPr>
           <p:cNvPicPr>
             <a:picLocks noChangeAspect="1"/>
           </p:cNvPicPr>
@@ -5757,7 +5757,7 @@
       </p:sp>
       <p:pic>
         <p:nvPicPr>
-          <p:cNvPr id="3" name="Image 0" descr="/home/claude/deckbuild/pngwarm/fig-03-governance-lag.png">    </p:cNvPr>
+          <p:cNvPr id="3" name="Image 0" descr="fig-03-governance-lag.png">    </p:cNvPr>
           <p:cNvPicPr>
             <a:picLocks noChangeAspect="1"/>
           </p:cNvPicPr>
@@ -6147,7 +6147,7 @@
       </p:sp>
       <p:pic>
         <p:nvPicPr>
-          <p:cNvPr id="3" name="Image 0" descr="/home/claude/deckbuild/pngwarm/fig-04-justification-half-life.png">    </p:cNvPr>
+          <p:cNvPr id="3" name="Image 0" descr="fig-04-justification-half-life.png">    </p:cNvPr>
           <p:cNvPicPr>
             <a:picLocks noChangeAspect="1"/>
           </p:cNvPicPr>
@@ -6171,7 +6171,7 @@
       </p:pic>
       <p:pic>
         <p:nvPicPr>
-          <p:cNvPr id="4" name="Image 1" descr="/home/claude/deckbuild/pngwarm/fig-05-trust-gradient.png">    </p:cNvPr>
+          <p:cNvPr id="4" name="Image 1" descr="fig-05-trust-gradient.png">    </p:cNvPr>
           <p:cNvPicPr>
             <a:picLocks noChangeAspect="1"/>
           </p:cNvPicPr>
@@ -6354,7 +6354,7 @@
       </p:sp>
       <p:pic>
         <p:nvPicPr>
-          <p:cNvPr id="3" name="Image 0" descr="/home/claude/deckbuild/pngwarm/d-gap.png">    </p:cNvPr>
+          <p:cNvPr id="3" name="Image 0" descr="d-gap.png">    </p:cNvPr>
           <p:cNvPicPr>
             <a:picLocks noChangeAspect="1"/>
           </p:cNvPicPr>
@@ -6495,7 +6495,7 @@
       </p:sp>
       <p:pic>
         <p:nvPicPr>
-          <p:cNvPr id="3" name="Image 0" descr="/home/claude/deckbuild/pngwarm/d-trend.png">    </p:cNvPr>
+          <p:cNvPr id="3" name="Image 0" descr="d-trend.png">    </p:cNvPr>
           <p:cNvPicPr>
             <a:picLocks noChangeAspect="1"/>
           </p:cNvPicPr>
@@ -6792,7 +6792,7 @@
       </p:sp>
       <p:pic>
         <p:nvPicPr>
-          <p:cNvPr id="3" name="Image 0" descr="/home/claude/deckbuild/pngwarm/d-fernway.png">    </p:cNvPr>
+          <p:cNvPr id="3" name="Image 0" descr="d-fernway.png">    </p:cNvPr>
           <p:cNvPicPr>
             <a:picLocks noChangeAspect="1"/>
           </p:cNvPicPr>
@@ -6933,7 +6933,7 @@
       </p:sp>
       <p:pic>
         <p:nvPicPr>
-          <p:cNvPr id="3" name="Image 0" descr="/home/claude/deckbuild/pngwarm/d-arc.png">    </p:cNvPr>
+          <p:cNvPr id="3" name="Image 0" descr="d-arc.png">    </p:cNvPr>
           <p:cNvPicPr>
             <a:picLocks noChangeAspect="1"/>
           </p:cNvPicPr>
@@ -7634,7 +7634,7 @@
       </p:sp>
       <p:pic>
         <p:nvPicPr>
-          <p:cNvPr id="3" name="Image 0" descr="/home/claude/deckbuild/pngwarm/d-form.png">    </p:cNvPr>
+          <p:cNvPr id="3" name="Image 0" descr="d-form.png">    </p:cNvPr>
           <p:cNvPicPr>
             <a:picLocks noChangeAspect="1"/>
           </p:cNvPicPr>
@@ -7892,7 +7892,7 @@
       </p:sp>
       <p:pic>
         <p:nvPicPr>
-          <p:cNvPr id="3" name="Image 0" descr="/home/claude/deckbuild/pngwarm/fig-01-framework-at-a-glance.png">    </p:cNvPr>
+          <p:cNvPr id="3" name="Image 0" descr="fig-01-framework-at-a-glance.png">    </p:cNvPr>
           <p:cNvPicPr>
             <a:picLocks noChangeAspect="1"/>
           </p:cNvPicPr>
@@ -9332,7 +9332,7 @@
       </p:sp>
       <p:pic>
         <p:nvPicPr>
-          <p:cNvPr id="3" name="Image 0" descr="/home/claude/deckbuild/pngwarm/strip-01-mandate.png">    </p:cNvPr>
+          <p:cNvPr id="3" name="Image 0" descr="strip-01-mandate.png">    </p:cNvPr>
           <p:cNvPicPr>
             <a:picLocks noChangeAspect="1"/>
           </p:cNvPicPr>
@@ -9395,7 +9395,7 @@
       </p:sp>
       <p:pic>
         <p:nvPicPr>
-          <p:cNvPr id="5" name="Image 1" descr="/home/claude/deckbuild/pngwarm/d-layer1.png">    </p:cNvPr>
+          <p:cNvPr id="5" name="Image 1" descr="d-layer1.png">    </p:cNvPr>
           <p:cNvPicPr>
             <a:picLocks noChangeAspect="1"/>
           </p:cNvPicPr>
@@ -9680,7 +9680,7 @@
       </p:sp>
       <p:pic>
         <p:nvPicPr>
-          <p:cNvPr id="3" name="Image 0" descr="/home/claude/deckbuild/pngwarm/strip-02-ownership.png">    </p:cNvPr>
+          <p:cNvPr id="3" name="Image 0" descr="strip-02-ownership.png">    </p:cNvPr>
           <p:cNvPicPr>
             <a:picLocks noChangeAspect="1"/>
           </p:cNvPicPr>
@@ -9743,7 +9743,7 @@
       </p:sp>
       <p:pic>
         <p:nvPicPr>
-          <p:cNvPr id="5" name="Image 1" descr="/home/claude/deckbuild/pngwarm/d-layer2.png">    </p:cNvPr>
+          <p:cNvPr id="5" name="Image 1" descr="d-layer2.png">    </p:cNvPr>
           <p:cNvPicPr>
             <a:picLocks noChangeAspect="1"/>
           </p:cNvPicPr>
@@ -10028,7 +10028,7 @@
       </p:sp>
       <p:pic>
         <p:nvPicPr>
-          <p:cNvPr id="3" name="Image 0" descr="/home/claude/deckbuild/pngwarm/strip-03-scope.png">    </p:cNvPr>
+          <p:cNvPr id="3" name="Image 0" descr="strip-03-scope.png">    </p:cNvPr>
           <p:cNvPicPr>
             <a:picLocks noChangeAspect="1"/>
           </p:cNvPicPr>
@@ -10091,7 +10091,7 @@
       </p:sp>
       <p:pic>
         <p:nvPicPr>
-          <p:cNvPr id="5" name="Image 1" descr="/home/claude/deckbuild/pngwarm/d-layer3.png">    </p:cNvPr>
+          <p:cNvPr id="5" name="Image 1" descr="d-layer3.png">    </p:cNvPr>
           <p:cNvPicPr>
             <a:picLocks noChangeAspect="1"/>
           </p:cNvPicPr>

</xml_diff>